<commit_message>
docs(lg): nombre del desarrollador Jorge Mtnez y nota sobre la verificación del Magic Remote sin hardware
Co-Authored-By: Claude Fable 5.1 <noreply@anthropic.com>
</commit_message>
<xml_diff>
--- a/docs/store-assets/lg/ux_scenario_easy_xtream_football.pptx
+++ b/docs/store-assets/lg/ux_scenario_easy_xtream_football.pptx
@@ -1557,7 +1557,7 @@
                             <a:srgbClr val="202020"/>
                           </a:solidFill>
                         </a:rPr>
-                        <a:t>Nezor</a:t>
+                        <a:t>Jorge Mtnez</a:t>
                       </a:r>
                     </a:p>
                   </a:txBody>
@@ -6036,7 +6036,7 @@
                   <a:srgbClr val="202020"/>
                 </a:solidFill>
               </a:rPr>
-              <a:t>- Tested on an LG 32LM637BPLA (webOS 4.9) with a real IPTV subscription (MPEG-TS, H.264, AC-3) and with the test playlists; Magic Remote behaviour verified with pointer events.</a:t>
+              <a:t>- Tested on an LG 32LM637BPLA (webOS 4.9) with a real IPTV subscription (MPEG-TS, H.264, AC-3) and with the test playlists; Magic Remote behaviour verified with pointer/wheel events in a desktop browser (no Magic Remote was available for a hardware check).</a:t>
             </a:r>
           </a:p>
           <a:p>

</xml_diff>

<commit_message>
chore(webos): versión 1.0.0 para LG Content Store (Seller Lounge exige File Version >= 1.0.0)
Co-Authored-By: Claude Fable 5.1 <noreply@anthropic.com>
</commit_message>
<xml_diff>
--- a/docs/store-assets/lg/ux_scenario_easy_xtream_football.pptx
+++ b/docs/store-assets/lg/ux_scenario_easy_xtream_football.pptx
@@ -1513,7 +1513,7 @@
                             <a:srgbClr val="202020"/>
                           </a:solidFill>
                         </a:rPr>
-                        <a:t>0.1.12</a:t>
+                        <a:t>1.0.0</a:t>
                       </a:r>
                     </a:p>
                   </a:txBody>
@@ -6510,7 +6510,7 @@
                             <a:srgbClr val="202020"/>
                           </a:solidFill>
                         </a:rPr>
-                        <a:t>0.1.12</a:t>
+                        <a:t>1.0.0</a:t>
                       </a:r>
                     </a:p>
                   </a:txBody>
@@ -7218,7 +7218,7 @@
                             <a:srgbClr val="202020"/>
                           </a:solidFill>
                         </a:rPr>
-                        <a:t>0.1.12</a:t>
+                        <a:t>1.0.0</a:t>
                       </a:r>
                     </a:p>
                   </a:txBody>

</xml_diff>